<commit_message>
Compare internal ids by reference target; regenerate run-fair
</commit_message>
<xml_diff>
--- a/evidence/2026-10-02/run-fair/raw/libreoffice/chart-data/measured-1.pptx
+++ b/evidence/2026-10-02/run-fair/raw/libreoffice/chart-data/measured-1.pptx
@@ -148,11 +148,11 @@
         </c:ser>
         <c:gapWidth val="150"/>
         <c:overlap val="0"/>
-        <c:axId val="56970770"/>
-        <c:axId val="81876715"/>
+        <c:axId val="22217533"/>
+        <c:axId val="46943830"/>
       </c:barChart>
       <c:catAx>
-        <c:axId val="56970770"/>
+        <c:axId val="22217533"/>
         <c:scaling>
           <c:orientation val="minMax"/>
         </c:scaling>
@@ -185,7 +185,7 @@
             </a:pPr>
           </a:p>
         </c:txPr>
-        <c:crossAx val="81876715"/>
+        <c:crossAx val="46943830"/>
         <c:crosses val="autoZero"/>
         <c:auto val="1"/>
         <c:lblAlgn val="ctr"/>
@@ -193,7 +193,7 @@
         <c:noMultiLvlLbl val="0"/>
       </c:catAx>
       <c:valAx>
-        <c:axId val="81876715"/>
+        <c:axId val="46943830"/>
         <c:scaling>
           <c:orientation val="minMax"/>
         </c:scaling>
@@ -236,7 +236,7 @@
             </a:pPr>
           </a:p>
         </c:txPr>
-        <c:crossAx val="56970770"/>
+        <c:crossAx val="22217533"/>
         <c:crosses val="autoZero"/>
         <c:crossBetween val="between"/>
       </c:valAx>
@@ -361,11 +361,11 @@
           </c:yVal>
           <c:smooth val="0"/>
         </c:ser>
-        <c:axId val="32957588"/>
-        <c:axId val="45034944"/>
+        <c:axId val="33030309"/>
+        <c:axId val="38223889"/>
       </c:scatterChart>
       <c:valAx>
-        <c:axId val="32957588"/>
+        <c:axId val="33030309"/>
         <c:scaling>
           <c:orientation val="minMax"/>
         </c:scaling>
@@ -398,12 +398,12 @@
             </a:pPr>
           </a:p>
         </c:txPr>
-        <c:crossAx val="45034944"/>
+        <c:crossAx val="38223889"/>
         <c:crosses val="autoZero"/>
         <c:crossBetween val="midCat"/>
       </c:valAx>
       <c:valAx>
-        <c:axId val="45034944"/>
+        <c:axId val="38223889"/>
         <c:scaling>
           <c:orientation val="minMax"/>
         </c:scaling>
@@ -446,7 +446,7 @@
             </a:pPr>
           </a:p>
         </c:txPr>
-        <c:crossAx val="32957588"/>
+        <c:crossAx val="33030309"/>
         <c:crosses val="autoZero"/>
         <c:crossBetween val="midCat"/>
       </c:valAx>
@@ -645,11 +645,11 @@
           </c:bubbleSize>
           <c:bubble3D val="0"/>
         </c:ser>
-        <c:axId val="88273171"/>
-        <c:axId val="46636327"/>
+        <c:axId val="74147220"/>
+        <c:axId val="73071182"/>
       </c:bubbleChart>
       <c:valAx>
-        <c:axId val="88273171"/>
+        <c:axId val="74147220"/>
         <c:scaling>
           <c:orientation val="minMax"/>
         </c:scaling>
@@ -682,12 +682,12 @@
             </a:pPr>
           </a:p>
         </c:txPr>
-        <c:crossAx val="46636327"/>
+        <c:crossAx val="73071182"/>
         <c:crosses val="autoZero"/>
         <c:crossBetween val="midCat"/>
       </c:valAx>
       <c:valAx>
-        <c:axId val="46636327"/>
+        <c:axId val="73071182"/>
         <c:scaling>
           <c:orientation val="minMax"/>
         </c:scaling>
@@ -730,7 +730,7 @@
             </a:pPr>
           </a:p>
         </c:txPr>
-        <c:crossAx val="88273171"/>
+        <c:crossAx val="74147220"/>
         <c:crosses val="autoZero"/>
         <c:crossBetween val="midCat"/>
       </c:valAx>
@@ -1731,7 +1731,7 @@
               </a:lnSpc>
               <a:buNone/>
             </a:pPr>
-            <a:fld id="{AFFE72A9-82CE-4919-93A4-D7AEB4CFF542}" type="slidenum">
+            <a:fld id="{45CB60D1-BC01-4FD5-8421-135F061D7D4B}" type="slidenum">
               <a:rPr lang="en-US" sz="1200" b="0" u="none" strike="noStrike">
                 <a:solidFill>
                   <a:schemeClr val="dk1">
@@ -2443,7 +2443,7 @@
               </a:lnSpc>
               <a:buNone/>
             </a:pPr>
-            <a:fld id="{5CD4C140-A526-46CE-9ECD-341A03A5E159}" type="slidenum">
+            <a:fld id="{3D390EF5-AC50-4A55-9BA7-131403AD8C20}" type="slidenum">
               <a:rPr lang="en-US" sz="1200" b="0" u="none" strike="noStrike">
                 <a:solidFill>
                   <a:schemeClr val="dk1">
@@ -2902,7 +2902,7 @@
               </a:lnSpc>
               <a:buNone/>
             </a:pPr>
-            <a:fld id="{14E2A8F1-4672-456E-9B64-69E0855F5DCD}" type="slidenum">
+            <a:fld id="{317A30CD-4325-458B-9F46-EECD4265A412}" type="slidenum">
               <a:rPr lang="en-US" sz="1200" b="0" u="none" strike="noStrike">
                 <a:solidFill>
                   <a:schemeClr val="dk1">
@@ -3530,7 +3530,7 @@
               </a:lnSpc>
               <a:buNone/>
             </a:pPr>
-            <a:fld id="{F151C7CB-A920-4395-830C-BF0B0EF29DAC}" type="slidenum">
+            <a:fld id="{312F867D-E1F3-4F56-B8EB-AEE76754C50A}" type="slidenum">
               <a:rPr lang="en-US" sz="1200" b="0" u="none" strike="noStrike">
                 <a:solidFill>
                   <a:schemeClr val="dk1">
@@ -4158,7 +4158,7 @@
               </a:lnSpc>
               <a:buNone/>
             </a:pPr>
-            <a:fld id="{677C6BEC-B03C-4AB7-B3F4-730CC6CA5880}" type="slidenum">
+            <a:fld id="{E1F9F66A-E89D-4305-AC2C-D79B8811A7DE}" type="slidenum">
               <a:rPr lang="en-US" sz="1200" b="0" u="none" strike="noStrike">
                 <a:solidFill>
                   <a:schemeClr val="dk1">
@@ -4786,7 +4786,7 @@
               </a:lnSpc>
               <a:buNone/>
             </a:pPr>
-            <a:fld id="{CB0F728D-3CA1-49CB-B0CD-3022D016E454}" type="slidenum">
+            <a:fld id="{910696CC-53F1-4421-901C-AE18389EB24B}" type="slidenum">
               <a:rPr lang="en-US" sz="1200" b="0" u="none" strike="noStrike">
                 <a:solidFill>
                   <a:schemeClr val="dk1">
@@ -5198,7 +5198,7 @@
               </a:lnSpc>
               <a:buNone/>
             </a:pPr>
-            <a:fld id="{4D3E284D-F347-4222-9918-5126C7C9A388}" type="slidenum">
+            <a:fld id="{E25CB418-B55E-4258-8CFA-1736C83B92EC}" type="slidenum">
               <a:rPr lang="en-US" sz="1200" b="0" u="none" strike="noStrike">
                 <a:solidFill>
                   <a:schemeClr val="dk1">
@@ -6132,7 +6132,7 @@
               </a:lnSpc>
               <a:buNone/>
             </a:pPr>
-            <a:fld id="{8C49981F-33BE-4F40-8821-92006B64E095}" type="slidenum">
+            <a:fld id="{C1C56E49-3291-4A27-B135-B229A8F4A86E}" type="slidenum">
               <a:rPr lang="en-US" sz="1200" b="0" u="none" strike="noStrike">
                 <a:solidFill>
                   <a:schemeClr val="dk1">
@@ -7294,7 +7294,7 @@
               </a:lnSpc>
               <a:buNone/>
             </a:pPr>
-            <a:fld id="{FCE33D4A-14AE-4B15-8397-B939ACED699C}" type="slidenum">
+            <a:fld id="{6D5BDED9-DF27-46AF-BAFC-4FE828A2626F}" type="slidenum">
               <a:rPr lang="en-US" sz="1200" b="0" u="none" strike="noStrike">
                 <a:solidFill>
                   <a:schemeClr val="dk1">
@@ -7616,7 +7616,7 @@
               </a:lnSpc>
               <a:buNone/>
             </a:pPr>
-            <a:fld id="{79535E3E-AED4-4B74-A26E-BDA293E649C0}" type="slidenum">
+            <a:fld id="{62CE8A31-8ECF-42B8-90C5-F482D5D89EAF}" type="slidenum">
               <a:rPr lang="en-US" sz="1200" b="0" u="none" strike="noStrike">
                 <a:solidFill>
                   <a:schemeClr val="dk1">
@@ -7866,7 +7866,7 @@
               </a:lnSpc>
               <a:buNone/>
             </a:pPr>
-            <a:fld id="{32CC5215-92C4-4717-B8D1-7930CB4B9511}" type="slidenum">
+            <a:fld id="{AD44F541-E851-4C1F-AA2E-374E48DDD288}" type="slidenum">
               <a:rPr lang="en-US" sz="1200" b="0" u="none" strike="noStrike">
                 <a:solidFill>
                   <a:schemeClr val="dk1">

</xml_diff>